<commit_message>
Proofread global-piqa slides page by page with Gemini
</commit_message>
<xml_diff>
--- a/slides/datasets-in-10-minutes-global-piqa.pptx
+++ b/slides/datasets-in-10-minutes-global-piqa.pptx
@@ -7487,7 +7487,7 @@
                 <a:ea typeface="Noto Sans CJK JP"/>
                 <a:cs typeface="Noto Sans"/>
               </a:rPr>
-              <a:t>parallel集合は、文化的な固有名への依存を抑えた共通問題を各言語へ訳す。物の性質・位置関係・時間・簡単な個数などを扱う。</a:t>
+              <a:t>parallel集合では、文化的な固有名への依存を抑えた共通問題を各言語へ訳す。物の性質・位置関係・時間・簡単な個数などを扱う。</a:t>
             </a:r>
           </a:p>
           <a:p>
@@ -11551,7 +11551,7 @@
                 <a:ea typeface="Noto Sans CJK JP"/>
                 <a:cs typeface="Noto Sans"/>
               </a:rPr>
-              <a:t>英語・日本語・スペイン語は103問、エクペイ語は101問。</a:t>
+              <a:t>英語・日本語・ペルーのスペイン語は103問、エクペイ語は101問。</a:t>
             </a:r>
           </a:p>
         </p:txBody>
@@ -12360,7 +12360,7 @@
                 <a:ea typeface="Noto Sans CJK JP"/>
                 <a:cs typeface="Noto Sans"/>
               </a:rPr>
-              <a:t>独自問題を整え、各言語100問へそろえる</a:t>
+              <a:t>独自問題を整え、各言語100問にそろえる</a:t>
             </a:r>
           </a:p>
         </p:txBody>
@@ -12734,7 +12734,7 @@
                           <a:ea typeface="Noto Sans CJK JP"/>
                           <a:cs typeface="Noto Sans"/>
                         </a:rPr>
-                        <a:t>母語話者が自然さ・正解・日常性を確認</a:t>
+                        <a:t>母語話者が自然さ・正解・日常性を確認する</a:t>
                       </a:r>
                     </a:p>
                   </a:txBody>
@@ -12836,7 +12836,7 @@
                           <a:ea typeface="Noto Sans CJK JP"/>
                           <a:cs typeface="Noto Sans"/>
                         </a:rPr>
-                        <a:t>形式を統一し、英訳と文化的特徴を注釈</a:t>
+                        <a:t>形式を統一し、英訳と文化的特徴を注記する</a:t>
                       </a:r>
                     </a:p>
                   </a:txBody>
@@ -14137,7 +14137,7 @@
                 <a:ea typeface="Noto Sans CJK JP"/>
                 <a:cs typeface="Noto Sans"/>
               </a:rPr>
-              <a:t>英語母語話者が109問を作り、Gemini 2.5 ProまたはGemini 3 Flashで翻訳した。対象言語の母語話者が訳文と正解を確認する。</a:t>
+              <a:t>英語母語話者が109問を作り、Gemini 2.5 ProまたはGemini 3 Flashで翻訳した。対象言語の母語話者が訳文と正解を確認した。</a:t>
             </a:r>
           </a:p>
           <a:p>
@@ -14167,7 +14167,7 @@
                 <a:ea typeface="Noto Sans CJK JP"/>
                 <a:cs typeface="Noto Sans"/>
               </a:rPr>
-              <a:t>訳語に「溶ける」と「溶解する」の区別がない場合や、元の問題が曖昧な場合に除外し、最終103問とした。</a:t>
+              <a:t>訳語で「溶ける」と「溶解する」を区別できない問題や、元の内容が曖昧な問題を除外し、最終103問とした。</a:t>
             </a:r>
           </a:p>
           <a:p>
@@ -14197,7 +14197,7 @@
                 <a:ea typeface="Noto Sans CJK JP"/>
                 <a:cs typeface="Noto Sans"/>
               </a:rPr>
-              <a:t>131種類の言語に展開した。エクペイ語では方角を扱う2問も除いたため101問となり、合計13,491問を配布する。</a:t>
+              <a:t>131種類の言語に展開した。エクペイ語では方角を扱う2問も除いたため101問となり、合計13,491問を配布している。</a:t>
             </a:r>
           </a:p>
         </p:txBody>
@@ -14985,7 +14985,7 @@
                           <a:ea typeface="Noto Sans CJK JP"/>
                           <a:cs typeface="Noto Sans"/>
                         </a:rPr>
-                        <a:t>両集合での言語の種類</a:t>
+                        <a:t>両集合を合わせた言語の種類</a:t>
                       </a:r>
                     </a:p>
                   </a:txBody>
@@ -15470,7 +15470,7 @@
                 <a:spcPts val="2640"/>
               </a:lnSpc>
               <a:spcAft>
-                <a:spcPts val="800"/>
+                <a:spcPts val="0"/>
               </a:spcAft>
               <a:buSzPct val="60455"/>
               <a:buFont typeface="Noto Sans CJK JP"/>
@@ -15491,7 +15491,7 @@
                 <a:ea typeface="Noto Sans CJK JP"/>
                 <a:cs typeface="Noto Sans"/>
               </a:rPr>
-              <a:t>non-parallelは、各言語の話者が選んだ地域の日常を扱う。言語ごとに固有の生活習慣や道具を問う問題がある。</a:t>
+              <a:t>元になったPIQAは、物体の性質や使い方を扱う英語の二択評価。Global PIQAはその形式を、多言語と文化ごとの常識へ広げた。</a:t>
             </a:r>
           </a:p>
           <a:p>
@@ -15521,7 +15521,7 @@
                 <a:ea typeface="Noto Sans CJK JP"/>
                 <a:cs typeface="Noto Sans"/>
               </a:rPr>
-              <a:t>parallelは、共通の場面を多言語へ訳す。言語の違いと、同じモデルの回答の変化を調べるために使う。</a:t>
+              <a:t>non-parallelは、各言語の話者が選んだ地域の日常を扱う。言語ごとに固有の生活習慣や道具を問う問題がある。</a:t>
             </a:r>
           </a:p>
           <a:p>
@@ -15530,7 +15530,7 @@
                 <a:spcPts val="2640"/>
               </a:lnSpc>
               <a:spcAft>
-                <a:spcPts val="0"/>
+                <a:spcPts val="800"/>
               </a:spcAft>
               <a:buSzPct val="60455"/>
               <a:buFont typeface="Noto Sans CJK JP"/>
@@ -15551,7 +15551,7 @@
                 <a:ea typeface="Noto Sans CJK JP"/>
                 <a:cs typeface="Noto Sans"/>
               </a:rPr>
-              <a:t>元になったPIQAは、物体の性質や使い方を扱う英語の二択評価。Global PIQAはその形式から、多言語と文化ごとの常識へ広げた。</a:t>
+              <a:t>parallelは、共通の場面を多言語へ翻訳したもの。同じモデルの回答が言語間でどう変わるかを調べるために使う。</a:t>
             </a:r>
           </a:p>
         </p:txBody>
@@ -22771,7 +22771,7 @@
                           <a:ea typeface="Noto Sans CJK JP"/>
                           <a:cs typeface="Noto Sans"/>
                         </a:rPr>
-                        <a:t>対応する種類</a:t>
+                        <a:t>言語・文字・地域</a:t>
                       </a:r>
                     </a:p>
                   </a:txBody>
@@ -24390,7 +24390,7 @@
                 <a:ea typeface="Noto Sans CJK JP"/>
                 <a:cs typeface="Noto Sans"/>
               </a:rPr>
-              <a:t>掲載した日本語non-parallelの問題は、llm_usedが1。Global PIQA全体での割合4.1%と、日本語のこの選定例の属性を確認できる。</a:t>
+              <a:t>掲載した日本語non-parallelの問題はllm_usedが1である。Global PIQA全体での割合4.1%とともに、日本語のこの選定例の属性を確認できる。</a:t>
             </a:r>
           </a:p>
           <a:p>
@@ -24420,7 +24420,7 @@
                 <a:ea typeface="Noto Sans CJK JP"/>
                 <a:cs typeface="Noto Sans"/>
               </a:rPr>
-              <a:t>データカードは、LLMの補助を用いた例も含め、すべて少なくとも一人の母語話者が確認したと説明する。</a:t>
+              <a:t>データカードには、LLMの補助を用いた例も含め、すべて少なくとも一人の母語話者が確認したと記載されている。</a:t>
             </a:r>
           </a:p>
           <a:p>
@@ -25761,18 +25761,18 @@
               <a:spcAft>
                 <a:spcPts val="800"/>
               </a:spcAft>
-              <a:buSzPct val="66500"/>
+              <a:buSzPct val="71892"/>
               <a:buFont typeface="Noto Sans CJK JP"/>
               <a:buChar char="●"/>
-              <a:defRPr sz="2000" b="0">
-                <a:solidFill>
-                  <a:srgbClr val="303437"/>
-                </a:solidFill>
-                <a:latin typeface="Noto Sans"/>
-              </a:defRPr>
-            </a:pPr>
-            <a:r>
-              <a:rPr sz="2000" b="0" lang="ja-JP" altLang="en-US">
+              <a:defRPr sz="1850" b="0">
+                <a:solidFill>
+                  <a:srgbClr val="303437"/>
+                </a:solidFill>
+                <a:latin typeface="Noto Sans"/>
+              </a:defRPr>
+            </a:pPr>
+            <a:r>
+              <a:rPr sz="1850" b="0" lang="ja-JP" altLang="en-US">
                 <a:solidFill>
                   <a:srgbClr val="303437"/>
                 </a:solidFill>
@@ -25791,18 +25791,18 @@
               <a:spcAft>
                 <a:spcPts val="800"/>
               </a:spcAft>
-              <a:buSzPct val="66500"/>
+              <a:buSzPct val="71892"/>
               <a:buFont typeface="Noto Sans CJK JP"/>
               <a:buChar char="●"/>
-              <a:defRPr sz="2000" b="0">
-                <a:solidFill>
-                  <a:srgbClr val="303437"/>
-                </a:solidFill>
-                <a:latin typeface="Noto Sans"/>
-              </a:defRPr>
-            </a:pPr>
-            <a:r>
-              <a:rPr sz="2000" b="0" lang="ja-JP" altLang="en-US">
+              <a:defRPr sz="1850" b="0">
+                <a:solidFill>
+                  <a:srgbClr val="303437"/>
+                </a:solidFill>
+                <a:latin typeface="Noto Sans"/>
+              </a:defRPr>
+            </a:pPr>
+            <a:r>
+              <a:rPr sz="1850" b="0" lang="ja-JP" altLang="en-US">
                 <a:solidFill>
                   <a:srgbClr val="303437"/>
                 </a:solidFill>
@@ -25821,26 +25821,26 @@
               <a:spcAft>
                 <a:spcPts val="0"/>
               </a:spcAft>
-              <a:buSzPct val="66500"/>
+              <a:buSzPct val="71892"/>
               <a:buFont typeface="Noto Sans CJK JP"/>
               <a:buChar char="●"/>
-              <a:defRPr sz="2000" b="0">
-                <a:solidFill>
-                  <a:srgbClr val="303437"/>
-                </a:solidFill>
-                <a:latin typeface="Noto Sans"/>
-              </a:defRPr>
-            </a:pPr>
-            <a:r>
-              <a:rPr sz="2000" b="0" lang="ja-JP" altLang="en-US">
-                <a:solidFill>
-                  <a:srgbClr val="303437"/>
-                </a:solidFill>
-                <a:latin typeface="Noto Sans"/>
-                <a:ea typeface="Noto Sans CJK JP"/>
-                <a:cs typeface="Noto Sans"/>
-              </a:rPr>
-              <a:t>データはCC BY-SA 4.0で、掲載例と追加した日本語訳も同ライセンス。提供元はAIシステムの学習や、その種データとしての使用を認めないと明記する。</a:t>
+              <a:defRPr sz="1850" b="0">
+                <a:solidFill>
+                  <a:srgbClr val="303437"/>
+                </a:solidFill>
+                <a:latin typeface="Noto Sans"/>
+              </a:defRPr>
+            </a:pPr>
+            <a:r>
+              <a:rPr sz="1850" b="0" lang="ja-JP" altLang="en-US">
+                <a:solidFill>
+                  <a:srgbClr val="303437"/>
+                </a:solidFill>
+                <a:latin typeface="Noto Sans"/>
+                <a:ea typeface="Noto Sans CJK JP"/>
+                <a:cs typeface="Noto Sans"/>
+              </a:rPr>
+              <a:t>データはCC BY-SA 4.0で、掲載例と追加した日本語訳も同ライセンス。提供元は、Global PIQA自体や、それを種に生成した合成データによるAIシステムの学習を認めないと明記している。</a:t>
             </a:r>
           </a:p>
         </p:txBody>
@@ -26272,7 +26272,7 @@
                 <a:ea typeface="Noto Sans CJK JP"/>
                 <a:cs typeface="Noto Sans"/>
               </a:rPr>
-              <a:t>原著は全著者と各チームの所属・データ作成方法を付録に掲載する。公開の全著者リストの最終著者はDavid Ifeoluwa Adelani。</a:t>
+              <a:t>原著では全著者と各チームの所属・データ作成方法が付録に掲載されている。公開された全著者リストの最終著者はDavid Ifeoluwa Adelani。</a:t>
             </a:r>
           </a:p>
         </p:txBody>

</xml_diff>